<commit_message>
Agregamos Filtros en Index de Workorders
</commit_message>
<xml_diff>
--- a/SAGM.pptx
+++ b/SAGM.pptx
@@ -5,15 +5,16 @@
     <p:sldMasterId id="2147483648" r:id="rId1"/>
   </p:sldMasterIdLst>
   <p:notesMasterIdLst>
-    <p:notesMasterId r:id="rId8"/>
+    <p:notesMasterId r:id="rId9"/>
   </p:notesMasterIdLst>
   <p:sldIdLst>
     <p:sldId id="261" r:id="rId2"/>
     <p:sldId id="262" r:id="rId3"/>
     <p:sldId id="257" r:id="rId4"/>
-    <p:sldId id="263" r:id="rId5"/>
-    <p:sldId id="265" r:id="rId6"/>
-    <p:sldId id="264" r:id="rId7"/>
+    <p:sldId id="266" r:id="rId5"/>
+    <p:sldId id="263" r:id="rId6"/>
+    <p:sldId id="265" r:id="rId7"/>
+    <p:sldId id="264" r:id="rId8"/>
   </p:sldIdLst>
   <p:sldSz cx="12192000" cy="6858000"/>
   <p:notesSz cx="6858000" cy="9144000"/>
@@ -202,7 +203,7 @@
           <a:p>
             <a:fld id="{74871CC2-F611-4804-B54B-022BD3A72DE2}" type="datetimeFigureOut">
               <a:rPr lang="en-US" smtClean="0"/>
-              <a:t>1/21/2026</a:t>
+              <a:t>8/4/2026</a:t>
             </a:fld>
             <a:endParaRPr lang="en-US"/>
           </a:p>
@@ -616,7 +617,7 @@
           <a:p>
             <a:fld id="{F6C4BC12-63D2-448A-B3B2-42DFD6961792}" type="datetime1">
               <a:rPr lang="en-US" smtClean="0"/>
-              <a:t>1/21/2026</a:t>
+              <a:t>8/4/2026</a:t>
             </a:fld>
             <a:endParaRPr lang="en-US"/>
           </a:p>
@@ -814,7 +815,7 @@
           <a:p>
             <a:fld id="{BD934D17-DDE2-4C88-93E4-E813399140E6}" type="datetime1">
               <a:rPr lang="en-US" smtClean="0"/>
-              <a:t>1/21/2026</a:t>
+              <a:t>8/4/2026</a:t>
             </a:fld>
             <a:endParaRPr lang="en-US"/>
           </a:p>
@@ -1022,7 +1023,7 @@
           <a:p>
             <a:fld id="{DD3A38BC-842E-45CE-BCF8-E1CBC20C614C}" type="datetime1">
               <a:rPr lang="en-US" smtClean="0"/>
-              <a:t>1/21/2026</a:t>
+              <a:t>8/4/2026</a:t>
             </a:fld>
             <a:endParaRPr lang="en-US"/>
           </a:p>
@@ -1225,7 +1226,7 @@
           <a:p>
             <a:fld id="{B7B30F97-193F-472E-870D-F04C5B9DA5FB}" type="datetime1">
               <a:rPr lang="en-US" smtClean="0"/>
-              <a:t>1/21/2026</a:t>
+              <a:t>8/4/2026</a:t>
             </a:fld>
             <a:endParaRPr lang="en-US"/>
           </a:p>
@@ -1510,7 +1511,7 @@
           <a:p>
             <a:fld id="{6EA26E18-504F-4A5B-85FE-498A8F3DA6D6}" type="datetime1">
               <a:rPr lang="en-US" smtClean="0"/>
-              <a:t>1/21/2026</a:t>
+              <a:t>8/4/2026</a:t>
             </a:fld>
             <a:endParaRPr lang="en-US"/>
           </a:p>
@@ -1775,7 +1776,7 @@
           <a:p>
             <a:fld id="{2B026C9F-4C4B-443C-A2FD-DE7507CFFC7A}" type="datetime1">
               <a:rPr lang="en-US" smtClean="0"/>
-              <a:t>1/21/2026</a:t>
+              <a:t>8/4/2026</a:t>
             </a:fld>
             <a:endParaRPr lang="en-US"/>
           </a:p>
@@ -2187,7 +2188,7 @@
           <a:p>
             <a:fld id="{98603F5F-3DB3-4819-B57C-FCFF5A274BA5}" type="datetime1">
               <a:rPr lang="en-US" smtClean="0"/>
-              <a:t>1/21/2026</a:t>
+              <a:t>8/4/2026</a:t>
             </a:fld>
             <a:endParaRPr lang="en-US"/>
           </a:p>
@@ -2328,7 +2329,7 @@
           <a:p>
             <a:fld id="{75699F17-7C13-49F3-9D3E-6935BEAF71AA}" type="datetime1">
               <a:rPr lang="en-US" smtClean="0"/>
-              <a:t>1/21/2026</a:t>
+              <a:t>8/4/2026</a:t>
             </a:fld>
             <a:endParaRPr lang="en-US"/>
           </a:p>
@@ -2441,7 +2442,7 @@
           <a:p>
             <a:fld id="{3D0BD42D-1694-42DE-B133-F78C47E35770}" type="datetime1">
               <a:rPr lang="en-US" smtClean="0"/>
-              <a:t>1/21/2026</a:t>
+              <a:t>8/4/2026</a:t>
             </a:fld>
             <a:endParaRPr lang="en-US"/>
           </a:p>
@@ -2752,7 +2753,7 @@
           <a:p>
             <a:fld id="{5CDE5B3E-3D63-4619-9A6F-3EE72937B0A7}" type="datetime1">
               <a:rPr lang="en-US" smtClean="0"/>
-              <a:t>1/21/2026</a:t>
+              <a:t>8/4/2026</a:t>
             </a:fld>
             <a:endParaRPr lang="en-US"/>
           </a:p>
@@ -3040,7 +3041,7 @@
           <a:p>
             <a:fld id="{8BD71F3C-68C7-43B5-AE46-6E0AC7D9EED6}" type="datetime1">
               <a:rPr lang="en-US" smtClean="0"/>
-              <a:t>1/21/2026</a:t>
+              <a:t>8/4/2026</a:t>
             </a:fld>
             <a:endParaRPr lang="en-US"/>
           </a:p>
@@ -3290,7 +3291,7 @@
           <a:p>
             <a:fld id="{385EACEF-8001-4EB6-85BC-AD185BCDEF76}" type="datetime1">
               <a:rPr lang="en-US" smtClean="0"/>
-              <a:t>1/21/2026</a:t>
+              <a:t>8/4/2026</a:t>
             </a:fld>
             <a:endParaRPr lang="en-US"/>
           </a:p>
@@ -4347,6 +4348,710 @@
         <p:cNvPr id="1" name="">
           <a:extLst>
             <a:ext uri="{FF2B5EF4-FFF2-40B4-BE49-F238E27FC236}">
+              <a16:creationId xmlns:a16="http://schemas.microsoft.com/office/drawing/2014/main" id="{8D2A2F4E-C1EA-28B7-25FA-9CB01482A7F5}"/>
+            </a:ext>
+          </a:extLst>
+        </p:cNvPr>
+        <p:cNvGrpSpPr/>
+        <p:nvPr/>
+      </p:nvGrpSpPr>
+      <p:grpSpPr>
+        <a:xfrm>
+          <a:off x="0" y="0"/>
+          <a:ext cx="0" cy="0"/>
+          <a:chOff x="0" y="0"/>
+          <a:chExt cx="0" cy="0"/>
+        </a:xfrm>
+      </p:grpSpPr>
+      <p:sp>
+        <p:nvSpPr>
+          <p:cNvPr id="27" name="Rectángulo: esquinas redondeadas 26">
+            <a:extLst>
+              <a:ext uri="{FF2B5EF4-FFF2-40B4-BE49-F238E27FC236}">
+                <a16:creationId xmlns:a16="http://schemas.microsoft.com/office/drawing/2014/main" id="{FFA66B31-4D76-6104-42D3-D9F5025768D6}"/>
+              </a:ext>
+            </a:extLst>
+          </p:cNvPr>
+          <p:cNvSpPr/>
+          <p:nvPr/>
+        </p:nvSpPr>
+        <p:spPr>
+          <a:xfrm>
+            <a:off x="1023034" y="2962284"/>
+            <a:ext cx="7282765" cy="3692488"/>
+          </a:xfrm>
+          <a:prstGeom prst="roundRect">
+            <a:avLst/>
+          </a:prstGeom>
+          <a:noFill/>
+          <a:ln w="9525" cap="flat" cmpd="sng" algn="ctr">
+            <a:solidFill>
+              <a:schemeClr val="accent6"/>
+            </a:solidFill>
+            <a:prstDash val="solid"/>
+            <a:round/>
+            <a:headEnd type="none" w="med" len="med"/>
+            <a:tailEnd type="none" w="med" len="med"/>
+          </a:ln>
+        </p:spPr>
+        <p:style>
+          <a:lnRef idx="0">
+            <a:scrgbClr r="0" g="0" b="0"/>
+          </a:lnRef>
+          <a:fillRef idx="0">
+            <a:scrgbClr r="0" g="0" b="0"/>
+          </a:fillRef>
+          <a:effectRef idx="0">
+            <a:scrgbClr r="0" g="0" b="0"/>
+          </a:effectRef>
+          <a:fontRef idx="minor">
+            <a:schemeClr val="accent6"/>
+          </a:fontRef>
+        </p:style>
+        <p:txBody>
+          <a:bodyPr rtlCol="0" anchor="ctr"/>
+          <a:lstStyle/>
+          <a:p>
+            <a:pPr algn="ctr"/>
+            <a:endParaRPr lang="en-US"/>
+          </a:p>
+        </p:txBody>
+      </p:sp>
+      <p:sp>
+        <p:nvSpPr>
+          <p:cNvPr id="2" name="TextBox 5">
+            <a:extLst>
+              <a:ext uri="{FF2B5EF4-FFF2-40B4-BE49-F238E27FC236}">
+                <a16:creationId xmlns:a16="http://schemas.microsoft.com/office/drawing/2014/main" id="{5AE02399-AC37-1B43-6520-2D8FEE42C7FE}"/>
+              </a:ext>
+            </a:extLst>
+          </p:cNvPr>
+          <p:cNvSpPr txBox="1"/>
+          <p:nvPr/>
+        </p:nvSpPr>
+        <p:spPr>
+          <a:xfrm>
+            <a:off x="5476874" y="379095"/>
+            <a:ext cx="5781040" cy="400110"/>
+          </a:xfrm>
+          <a:prstGeom prst="rect">
+            <a:avLst/>
+          </a:prstGeom>
+          <a:noFill/>
+        </p:spPr>
+        <p:txBody>
+          <a:bodyPr wrap="square" rtlCol="0">
+            <a:spAutoFit/>
+          </a:bodyPr>
+          <a:lstStyle/>
+          <a:p>
+            <a:pPr algn="r"/>
+            <a:r>
+              <a:rPr lang="es-MX" sz="2000" b="1" dirty="0"/>
+              <a:t>Arquitectura del sistema</a:t>
+            </a:r>
+            <a:endParaRPr lang="en-US" dirty="0"/>
+          </a:p>
+        </p:txBody>
+      </p:sp>
+      <p:sp>
+        <p:nvSpPr>
+          <p:cNvPr id="13" name="Slide Number Placeholder 12">
+            <a:extLst>
+              <a:ext uri="{FF2B5EF4-FFF2-40B4-BE49-F238E27FC236}">
+                <a16:creationId xmlns:a16="http://schemas.microsoft.com/office/drawing/2014/main" id="{B98DAAD0-D780-7288-261E-086CEA92814F}"/>
+              </a:ext>
+            </a:extLst>
+          </p:cNvPr>
+          <p:cNvSpPr>
+            <a:spLocks noGrp="1"/>
+          </p:cNvSpPr>
+          <p:nvPr>
+            <p:ph type="sldNum" sz="quarter" idx="12"/>
+          </p:nvPr>
+        </p:nvSpPr>
+        <p:spPr/>
+        <p:txBody>
+          <a:bodyPr/>
+          <a:lstStyle/>
+          <a:p>
+            <a:fld id="{0DD1D0E6-76F4-4C79-BDAB-E751C35221FD}" type="slidenum">
+              <a:rPr lang="en-US" smtClean="0"/>
+              <a:t>4</a:t>
+            </a:fld>
+            <a:endParaRPr lang="en-US"/>
+          </a:p>
+        </p:txBody>
+      </p:sp>
+      <p:sp>
+        <p:nvSpPr>
+          <p:cNvPr id="5" name="CuadroTexto 4">
+            <a:extLst>
+              <a:ext uri="{FF2B5EF4-FFF2-40B4-BE49-F238E27FC236}">
+                <a16:creationId xmlns:a16="http://schemas.microsoft.com/office/drawing/2014/main" id="{04ED229A-F145-B17B-4B53-BA21C45E4786}"/>
+              </a:ext>
+            </a:extLst>
+          </p:cNvPr>
+          <p:cNvSpPr txBox="1"/>
+          <p:nvPr/>
+        </p:nvSpPr>
+        <p:spPr>
+          <a:xfrm>
+            <a:off x="356616" y="2176272"/>
+            <a:ext cx="11128248" cy="369332"/>
+          </a:xfrm>
+          <a:prstGeom prst="rect">
+            <a:avLst/>
+          </a:prstGeom>
+          <a:noFill/>
+        </p:spPr>
+        <p:txBody>
+          <a:bodyPr wrap="square" rtlCol="0">
+            <a:spAutoFit/>
+          </a:bodyPr>
+          <a:lstStyle/>
+          <a:p>
+            <a:r>
+              <a:rPr lang="es-MX" dirty="0"/>
+              <a:t>El sistema está basado en el ciclo de vida de un negocio, desde la prospección, venta, operación y </a:t>
+            </a:r>
+            <a:r>
+              <a:rPr lang="es-MX" dirty="0" err="1"/>
+              <a:t>admininstración</a:t>
+            </a:r>
+            <a:endParaRPr lang="en-US" dirty="0"/>
+          </a:p>
+        </p:txBody>
+      </p:sp>
+      <p:sp>
+        <p:nvSpPr>
+          <p:cNvPr id="8" name="CuadroTexto 7">
+            <a:extLst>
+              <a:ext uri="{FF2B5EF4-FFF2-40B4-BE49-F238E27FC236}">
+                <a16:creationId xmlns:a16="http://schemas.microsoft.com/office/drawing/2014/main" id="{AA4BEDFA-E6EE-3F9C-EB70-1F38B7E373A0}"/>
+              </a:ext>
+            </a:extLst>
+          </p:cNvPr>
+          <p:cNvSpPr txBox="1"/>
+          <p:nvPr/>
+        </p:nvSpPr>
+        <p:spPr>
+          <a:xfrm rot="16200000">
+            <a:off x="2828466" y="3804171"/>
+            <a:ext cx="1263658" cy="276999"/>
+          </a:xfrm>
+          <a:prstGeom prst="rect">
+            <a:avLst/>
+          </a:prstGeom>
+          <a:noFill/>
+        </p:spPr>
+        <p:txBody>
+          <a:bodyPr wrap="square" rtlCol="0">
+            <a:spAutoFit/>
+          </a:bodyPr>
+          <a:lstStyle/>
+          <a:p>
+            <a:r>
+              <a:rPr lang="es-MX" sz="1200" dirty="0"/>
+              <a:t>Cotización</a:t>
+            </a:r>
+            <a:endParaRPr lang="en-US" dirty="0"/>
+          </a:p>
+        </p:txBody>
+      </p:sp>
+      <p:sp>
+        <p:nvSpPr>
+          <p:cNvPr id="10" name="CuadroTexto 9">
+            <a:extLst>
+              <a:ext uri="{FF2B5EF4-FFF2-40B4-BE49-F238E27FC236}">
+                <a16:creationId xmlns:a16="http://schemas.microsoft.com/office/drawing/2014/main" id="{268CBF72-D0D7-307B-78E6-30285C15A99C}"/>
+              </a:ext>
+            </a:extLst>
+          </p:cNvPr>
+          <p:cNvSpPr txBox="1"/>
+          <p:nvPr/>
+        </p:nvSpPr>
+        <p:spPr>
+          <a:xfrm rot="16200000">
+            <a:off x="3317671" y="3868859"/>
+            <a:ext cx="678442" cy="276999"/>
+          </a:xfrm>
+          <a:prstGeom prst="rect">
+            <a:avLst/>
+          </a:prstGeom>
+          <a:noFill/>
+        </p:spPr>
+        <p:txBody>
+          <a:bodyPr wrap="square" rtlCol="0">
+            <a:spAutoFit/>
+          </a:bodyPr>
+          <a:lstStyle/>
+          <a:p>
+            <a:r>
+              <a:rPr lang="es-MX" sz="1200" dirty="0"/>
+              <a:t>OT</a:t>
+            </a:r>
+            <a:endParaRPr lang="en-US" sz="1200" dirty="0"/>
+          </a:p>
+        </p:txBody>
+      </p:sp>
+      <p:sp>
+        <p:nvSpPr>
+          <p:cNvPr id="14" name="Elipse 13">
+            <a:extLst>
+              <a:ext uri="{FF2B5EF4-FFF2-40B4-BE49-F238E27FC236}">
+                <a16:creationId xmlns:a16="http://schemas.microsoft.com/office/drawing/2014/main" id="{CA923310-D2C5-7DB0-179A-02D7DFBEF6F9}"/>
+              </a:ext>
+            </a:extLst>
+          </p:cNvPr>
+          <p:cNvSpPr/>
+          <p:nvPr/>
+        </p:nvSpPr>
+        <p:spPr>
+          <a:xfrm>
+            <a:off x="3822192" y="4489552"/>
+            <a:ext cx="2139695" cy="2057400"/>
+          </a:xfrm>
+          <a:prstGeom prst="ellipse">
+            <a:avLst/>
+          </a:prstGeom>
+        </p:spPr>
+        <p:style>
+          <a:lnRef idx="2">
+            <a:schemeClr val="accent2"/>
+          </a:lnRef>
+          <a:fillRef idx="1">
+            <a:schemeClr val="lt1"/>
+          </a:fillRef>
+          <a:effectRef idx="0">
+            <a:schemeClr val="accent2"/>
+          </a:effectRef>
+          <a:fontRef idx="minor">
+            <a:schemeClr val="dk1"/>
+          </a:fontRef>
+        </p:style>
+        <p:txBody>
+          <a:bodyPr rtlCol="0" anchor="ctr"/>
+          <a:lstStyle/>
+          <a:p>
+            <a:pPr algn="ctr"/>
+            <a:endParaRPr lang="en-US"/>
+          </a:p>
+        </p:txBody>
+      </p:sp>
+      <p:sp>
+        <p:nvSpPr>
+          <p:cNvPr id="22" name="CuadroTexto 21">
+            <a:extLst>
+              <a:ext uri="{FF2B5EF4-FFF2-40B4-BE49-F238E27FC236}">
+                <a16:creationId xmlns:a16="http://schemas.microsoft.com/office/drawing/2014/main" id="{8BE594F7-28BC-59A7-478C-C7CE293ED74C}"/>
+              </a:ext>
+            </a:extLst>
+          </p:cNvPr>
+          <p:cNvSpPr txBox="1"/>
+          <p:nvPr/>
+        </p:nvSpPr>
+        <p:spPr>
+          <a:xfrm>
+            <a:off x="4264151" y="5540300"/>
+            <a:ext cx="1938528" cy="369332"/>
+          </a:xfrm>
+          <a:prstGeom prst="rect">
+            <a:avLst/>
+          </a:prstGeom>
+          <a:noFill/>
+        </p:spPr>
+        <p:txBody>
+          <a:bodyPr wrap="square" rtlCol="0">
+            <a:spAutoFit/>
+          </a:bodyPr>
+          <a:lstStyle/>
+          <a:p>
+            <a:r>
+              <a:rPr lang="es-MX" dirty="0"/>
+              <a:t>Administración</a:t>
+            </a:r>
+            <a:endParaRPr lang="en-US" dirty="0"/>
+          </a:p>
+        </p:txBody>
+      </p:sp>
+      <p:sp>
+        <p:nvSpPr>
+          <p:cNvPr id="23" name="CuadroTexto 22">
+            <a:extLst>
+              <a:ext uri="{FF2B5EF4-FFF2-40B4-BE49-F238E27FC236}">
+                <a16:creationId xmlns:a16="http://schemas.microsoft.com/office/drawing/2014/main" id="{FF5C4DD0-34D9-7AD2-2CBF-90C2D108D257}"/>
+              </a:ext>
+            </a:extLst>
+          </p:cNvPr>
+          <p:cNvSpPr txBox="1"/>
+          <p:nvPr/>
+        </p:nvSpPr>
+        <p:spPr>
+          <a:xfrm>
+            <a:off x="4429423" y="4684967"/>
+            <a:ext cx="502920" cy="276999"/>
+          </a:xfrm>
+          <a:prstGeom prst="rect">
+            <a:avLst/>
+          </a:prstGeom>
+          <a:noFill/>
+        </p:spPr>
+        <p:txBody>
+          <a:bodyPr wrap="square" rtlCol="0">
+            <a:spAutoFit/>
+          </a:bodyPr>
+          <a:lstStyle/>
+          <a:p>
+            <a:r>
+              <a:rPr lang="es-MX" sz="1200" dirty="0"/>
+              <a:t>OC</a:t>
+            </a:r>
+            <a:endParaRPr lang="en-US" sz="1200" dirty="0"/>
+          </a:p>
+        </p:txBody>
+      </p:sp>
+      <p:sp>
+        <p:nvSpPr>
+          <p:cNvPr id="26" name="CuadroTexto 25">
+            <a:extLst>
+              <a:ext uri="{FF2B5EF4-FFF2-40B4-BE49-F238E27FC236}">
+                <a16:creationId xmlns:a16="http://schemas.microsoft.com/office/drawing/2014/main" id="{FEC0DCC0-C139-467B-98D2-7C4F6B9CA574}"/>
+              </a:ext>
+            </a:extLst>
+          </p:cNvPr>
+          <p:cNvSpPr txBox="1"/>
+          <p:nvPr/>
+        </p:nvSpPr>
+        <p:spPr>
+          <a:xfrm rot="16200000">
+            <a:off x="4523035" y="3645782"/>
+            <a:ext cx="1289304" cy="276999"/>
+          </a:xfrm>
+          <a:prstGeom prst="rect">
+            <a:avLst/>
+          </a:prstGeom>
+          <a:noFill/>
+        </p:spPr>
+        <p:txBody>
+          <a:bodyPr wrap="square" rtlCol="0">
+            <a:spAutoFit/>
+          </a:bodyPr>
+          <a:lstStyle/>
+          <a:p>
+            <a:r>
+              <a:rPr lang="es-MX" sz="1200" dirty="0"/>
+              <a:t>Facturas</a:t>
+            </a:r>
+            <a:endParaRPr lang="en-US" sz="1200" dirty="0"/>
+          </a:p>
+        </p:txBody>
+      </p:sp>
+      <p:sp>
+        <p:nvSpPr>
+          <p:cNvPr id="29" name="Elipse 28">
+            <a:extLst>
+              <a:ext uri="{FF2B5EF4-FFF2-40B4-BE49-F238E27FC236}">
+                <a16:creationId xmlns:a16="http://schemas.microsoft.com/office/drawing/2014/main" id="{9C9B869B-3552-AA9D-2D49-C0C216FBAA7C}"/>
+              </a:ext>
+            </a:extLst>
+          </p:cNvPr>
+          <p:cNvSpPr/>
+          <p:nvPr/>
+        </p:nvSpPr>
+        <p:spPr>
+          <a:xfrm>
+            <a:off x="1885851" y="3163693"/>
+            <a:ext cx="1964220" cy="1950185"/>
+          </a:xfrm>
+          <a:prstGeom prst="ellipse">
+            <a:avLst/>
+          </a:prstGeom>
+          <a:noFill/>
+          <a:ln w="9525" cap="flat" cmpd="sng" algn="ctr">
+            <a:solidFill>
+              <a:schemeClr val="accent6"/>
+            </a:solidFill>
+            <a:prstDash val="solid"/>
+            <a:round/>
+            <a:headEnd type="none" w="med" len="med"/>
+            <a:tailEnd type="none" w="med" len="med"/>
+          </a:ln>
+        </p:spPr>
+        <p:style>
+          <a:lnRef idx="0">
+            <a:scrgbClr r="0" g="0" b="0"/>
+          </a:lnRef>
+          <a:fillRef idx="0">
+            <a:scrgbClr r="0" g="0" b="0"/>
+          </a:fillRef>
+          <a:effectRef idx="0">
+            <a:scrgbClr r="0" g="0" b="0"/>
+          </a:effectRef>
+          <a:fontRef idx="minor">
+            <a:schemeClr val="accent6"/>
+          </a:fontRef>
+        </p:style>
+        <p:txBody>
+          <a:bodyPr rtlCol="0" anchor="ctr"/>
+          <a:lstStyle/>
+          <a:p>
+            <a:pPr algn="ctr"/>
+            <a:endParaRPr lang="en-US"/>
+          </a:p>
+        </p:txBody>
+      </p:sp>
+      <p:sp>
+        <p:nvSpPr>
+          <p:cNvPr id="30" name="CuadroTexto 29">
+            <a:extLst>
+              <a:ext uri="{FF2B5EF4-FFF2-40B4-BE49-F238E27FC236}">
+                <a16:creationId xmlns:a16="http://schemas.microsoft.com/office/drawing/2014/main" id="{B8CE6581-3788-53BE-0030-9E30A73FD35C}"/>
+              </a:ext>
+            </a:extLst>
+          </p:cNvPr>
+          <p:cNvSpPr txBox="1"/>
+          <p:nvPr/>
+        </p:nvSpPr>
+        <p:spPr>
+          <a:xfrm>
+            <a:off x="2301896" y="4007727"/>
+            <a:ext cx="1132130" cy="369332"/>
+          </a:xfrm>
+          <a:prstGeom prst="rect">
+            <a:avLst/>
+          </a:prstGeom>
+          <a:noFill/>
+        </p:spPr>
+        <p:txBody>
+          <a:bodyPr wrap="square" rtlCol="0">
+            <a:spAutoFit/>
+          </a:bodyPr>
+          <a:lstStyle/>
+          <a:p>
+            <a:r>
+              <a:rPr lang="es-MX" dirty="0"/>
+              <a:t>Ventas</a:t>
+            </a:r>
+            <a:endParaRPr lang="en-US" dirty="0"/>
+          </a:p>
+        </p:txBody>
+      </p:sp>
+      <p:sp>
+        <p:nvSpPr>
+          <p:cNvPr id="32" name="Elipse 31">
+            <a:extLst>
+              <a:ext uri="{FF2B5EF4-FFF2-40B4-BE49-F238E27FC236}">
+                <a16:creationId xmlns:a16="http://schemas.microsoft.com/office/drawing/2014/main" id="{6C4D5A14-BD7E-5F2B-F1E5-CD68913E5D73}"/>
+              </a:ext>
+            </a:extLst>
+          </p:cNvPr>
+          <p:cNvSpPr/>
+          <p:nvPr/>
+        </p:nvSpPr>
+        <p:spPr>
+          <a:xfrm>
+            <a:off x="3341967" y="3163693"/>
+            <a:ext cx="1964220" cy="1950185"/>
+          </a:xfrm>
+          <a:prstGeom prst="ellipse">
+            <a:avLst/>
+          </a:prstGeom>
+          <a:noFill/>
+          <a:ln w="9525" cap="flat" cmpd="sng" algn="ctr">
+            <a:solidFill>
+              <a:schemeClr val="accent4"/>
+            </a:solidFill>
+            <a:prstDash val="solid"/>
+            <a:round/>
+            <a:headEnd type="none" w="med" len="med"/>
+            <a:tailEnd type="none" w="med" len="med"/>
+          </a:ln>
+        </p:spPr>
+        <p:style>
+          <a:lnRef idx="0">
+            <a:scrgbClr r="0" g="0" b="0"/>
+          </a:lnRef>
+          <a:fillRef idx="0">
+            <a:scrgbClr r="0" g="0" b="0"/>
+          </a:fillRef>
+          <a:effectRef idx="0">
+            <a:scrgbClr r="0" g="0" b="0"/>
+          </a:effectRef>
+          <a:fontRef idx="minor">
+            <a:schemeClr val="accent4"/>
+          </a:fontRef>
+        </p:style>
+        <p:txBody>
+          <a:bodyPr rtlCol="0" anchor="ctr"/>
+          <a:lstStyle/>
+          <a:p>
+            <a:pPr algn="ctr"/>
+            <a:endParaRPr lang="en-US"/>
+          </a:p>
+        </p:txBody>
+      </p:sp>
+      <p:sp>
+        <p:nvSpPr>
+          <p:cNvPr id="33" name="CuadroTexto 32">
+            <a:extLst>
+              <a:ext uri="{FF2B5EF4-FFF2-40B4-BE49-F238E27FC236}">
+                <a16:creationId xmlns:a16="http://schemas.microsoft.com/office/drawing/2014/main" id="{CC57068E-67C7-56BA-C2A5-117A0627BC5A}"/>
+              </a:ext>
+            </a:extLst>
+          </p:cNvPr>
+          <p:cNvSpPr txBox="1"/>
+          <p:nvPr/>
+        </p:nvSpPr>
+        <p:spPr>
+          <a:xfrm>
+            <a:off x="3828655" y="3834850"/>
+            <a:ext cx="1250540" cy="369332"/>
+          </a:xfrm>
+          <a:prstGeom prst="rect">
+            <a:avLst/>
+          </a:prstGeom>
+          <a:noFill/>
+        </p:spPr>
+        <p:txBody>
+          <a:bodyPr wrap="square" rtlCol="0">
+            <a:spAutoFit/>
+          </a:bodyPr>
+          <a:lstStyle/>
+          <a:p>
+            <a:r>
+              <a:rPr lang="es-MX" dirty="0"/>
+              <a:t>Operación</a:t>
+            </a:r>
+            <a:endParaRPr lang="en-US" dirty="0"/>
+          </a:p>
+        </p:txBody>
+      </p:sp>
+      <p:sp>
+        <p:nvSpPr>
+          <p:cNvPr id="35" name="Elipse 34">
+            <a:extLst>
+              <a:ext uri="{FF2B5EF4-FFF2-40B4-BE49-F238E27FC236}">
+                <a16:creationId xmlns:a16="http://schemas.microsoft.com/office/drawing/2014/main" id="{C950F7A8-7C30-4163-11CD-8ACAE6ECC312}"/>
+              </a:ext>
+            </a:extLst>
+          </p:cNvPr>
+          <p:cNvSpPr/>
+          <p:nvPr/>
+        </p:nvSpPr>
+        <p:spPr>
+          <a:xfrm>
+            <a:off x="4932343" y="3217300"/>
+            <a:ext cx="1964220" cy="1950185"/>
+          </a:xfrm>
+          <a:prstGeom prst="ellipse">
+            <a:avLst/>
+          </a:prstGeom>
+          <a:noFill/>
+          <a:ln w="9525" cap="flat" cmpd="sng" algn="ctr">
+            <a:solidFill>
+              <a:schemeClr val="accent1"/>
+            </a:solidFill>
+            <a:prstDash val="solid"/>
+            <a:round/>
+            <a:headEnd type="none" w="med" len="med"/>
+            <a:tailEnd type="none" w="med" len="med"/>
+          </a:ln>
+        </p:spPr>
+        <p:style>
+          <a:lnRef idx="0">
+            <a:scrgbClr r="0" g="0" b="0"/>
+          </a:lnRef>
+          <a:fillRef idx="0">
+            <a:scrgbClr r="0" g="0" b="0"/>
+          </a:fillRef>
+          <a:effectRef idx="0">
+            <a:scrgbClr r="0" g="0" b="0"/>
+          </a:effectRef>
+          <a:fontRef idx="minor">
+            <a:schemeClr val="accent1"/>
+          </a:fontRef>
+        </p:style>
+        <p:txBody>
+          <a:bodyPr rtlCol="0" anchor="ctr"/>
+          <a:lstStyle/>
+          <a:p>
+            <a:pPr algn="ctr"/>
+            <a:endParaRPr lang="en-US"/>
+          </a:p>
+        </p:txBody>
+      </p:sp>
+      <p:sp>
+        <p:nvSpPr>
+          <p:cNvPr id="36" name="CuadroTexto 35">
+            <a:extLst>
+              <a:ext uri="{FF2B5EF4-FFF2-40B4-BE49-F238E27FC236}">
+                <a16:creationId xmlns:a16="http://schemas.microsoft.com/office/drawing/2014/main" id="{29822BE6-7E46-8B6A-5D41-5DA020E09C57}"/>
+              </a:ext>
+            </a:extLst>
+          </p:cNvPr>
+          <p:cNvSpPr txBox="1"/>
+          <p:nvPr/>
+        </p:nvSpPr>
+        <p:spPr>
+          <a:xfrm>
+            <a:off x="5582115" y="3942670"/>
+            <a:ext cx="1233046" cy="369332"/>
+          </a:xfrm>
+          <a:prstGeom prst="rect">
+            <a:avLst/>
+          </a:prstGeom>
+          <a:noFill/>
+        </p:spPr>
+        <p:txBody>
+          <a:bodyPr wrap="square" rtlCol="0">
+            <a:spAutoFit/>
+          </a:bodyPr>
+          <a:lstStyle/>
+          <a:p>
+            <a:r>
+              <a:rPr lang="es-MX" dirty="0"/>
+              <a:t>Finanzas</a:t>
+            </a:r>
+            <a:endParaRPr lang="en-US" dirty="0"/>
+          </a:p>
+        </p:txBody>
+      </p:sp>
+    </p:spTree>
+    <p:extLst>
+      <p:ext uri="{BB962C8B-B14F-4D97-AF65-F5344CB8AC3E}">
+        <p14:creationId xmlns:p14="http://schemas.microsoft.com/office/powerpoint/2010/main" val="1134735319"/>
+      </p:ext>
+    </p:extLst>
+  </p:cSld>
+  <p:clrMapOvr>
+    <a:masterClrMapping/>
+  </p:clrMapOvr>
+</p:sld>
+</file>
+
+<file path=ppt/slides/slide5.xml><?xml version="1.0" encoding="utf-8"?>
+<p:sld xmlns:a="http://schemas.openxmlformats.org/drawingml/2006/main" xmlns:r="http://schemas.openxmlformats.org/officeDocument/2006/relationships" xmlns:p="http://schemas.openxmlformats.org/presentationml/2006/main">
+  <p:cSld>
+    <p:bg>
+      <p:bgPr>
+        <a:blipFill dpi="0" rotWithShape="1">
+          <a:blip r:embed="rId2">
+            <a:lum/>
+          </a:blip>
+          <a:srcRect/>
+          <a:stretch>
+            <a:fillRect/>
+          </a:stretch>
+        </a:blipFill>
+        <a:effectLst/>
+      </p:bgPr>
+    </p:bg>
+    <p:spTree>
+      <p:nvGrpSpPr>
+        <p:cNvPr id="1" name="">
+          <a:extLst>
+            <a:ext uri="{FF2B5EF4-FFF2-40B4-BE49-F238E27FC236}">
               <a16:creationId xmlns:a16="http://schemas.microsoft.com/office/drawing/2014/main" id="{D4736E83-87DD-B282-C7C0-C23D47D1277D}"/>
             </a:ext>
           </a:extLst>
@@ -4422,7 +5127,7 @@
           <a:p>
             <a:fld id="{0DD1D0E6-76F4-4C79-BDAB-E751C35221FD}" type="slidenum">
               <a:rPr lang="en-US" smtClean="0"/>
-              <a:t>4</a:t>
+              <a:t>5</a:t>
             </a:fld>
             <a:endParaRPr lang="en-US"/>
           </a:p>
@@ -6241,6 +6946,88 @@
           </a:fontRef>
         </p:style>
       </p:cxnSp>
+      <p:cxnSp>
+        <p:nvCxnSpPr>
+          <p:cNvPr id="5" name="Straight Arrow Connector 41">
+            <a:extLst>
+              <a:ext uri="{FF2B5EF4-FFF2-40B4-BE49-F238E27FC236}">
+                <a16:creationId xmlns:a16="http://schemas.microsoft.com/office/drawing/2014/main" id="{5C653EE5-6F57-B66D-3E24-2332326B7CD0}"/>
+              </a:ext>
+            </a:extLst>
+          </p:cNvPr>
+          <p:cNvCxnSpPr>
+            <a:cxnSpLocks/>
+          </p:cNvCxnSpPr>
+          <p:nvPr/>
+        </p:nvCxnSpPr>
+        <p:spPr>
+          <a:xfrm>
+            <a:off x="3818053" y="3561849"/>
+            <a:ext cx="1200390" cy="788385"/>
+          </a:xfrm>
+          <a:prstGeom prst="straightConnector1">
+            <a:avLst/>
+          </a:prstGeom>
+          <a:ln>
+            <a:tailEnd type="triangle"/>
+          </a:ln>
+        </p:spPr>
+        <p:style>
+          <a:lnRef idx="1">
+            <a:schemeClr val="accent1"/>
+          </a:lnRef>
+          <a:fillRef idx="0">
+            <a:schemeClr val="accent1"/>
+          </a:fillRef>
+          <a:effectRef idx="0">
+            <a:schemeClr val="accent1"/>
+          </a:effectRef>
+          <a:fontRef idx="minor">
+            <a:schemeClr val="tx1"/>
+          </a:fontRef>
+        </p:style>
+      </p:cxnSp>
+      <p:cxnSp>
+        <p:nvCxnSpPr>
+          <p:cNvPr id="10" name="Straight Arrow Connector 41">
+            <a:extLst>
+              <a:ext uri="{FF2B5EF4-FFF2-40B4-BE49-F238E27FC236}">
+                <a16:creationId xmlns:a16="http://schemas.microsoft.com/office/drawing/2014/main" id="{CE39E2F8-0962-47CB-36A7-FD8D79D37C46}"/>
+              </a:ext>
+            </a:extLst>
+          </p:cNvPr>
+          <p:cNvCxnSpPr>
+            <a:cxnSpLocks/>
+          </p:cNvCxnSpPr>
+          <p:nvPr/>
+        </p:nvCxnSpPr>
+        <p:spPr>
+          <a:xfrm>
+            <a:off x="3818053" y="3561849"/>
+            <a:ext cx="1425468" cy="2545057"/>
+          </a:xfrm>
+          <a:prstGeom prst="straightConnector1">
+            <a:avLst/>
+          </a:prstGeom>
+          <a:ln>
+            <a:tailEnd type="triangle"/>
+          </a:ln>
+        </p:spPr>
+        <p:style>
+          <a:lnRef idx="1">
+            <a:schemeClr val="accent1"/>
+          </a:lnRef>
+          <a:fillRef idx="0">
+            <a:schemeClr val="accent1"/>
+          </a:fillRef>
+          <a:effectRef idx="0">
+            <a:schemeClr val="accent1"/>
+          </a:effectRef>
+          <a:fontRef idx="minor">
+            <a:schemeClr val="tx1"/>
+          </a:fontRef>
+        </p:style>
+      </p:cxnSp>
     </p:spTree>
     <p:extLst>
       <p:ext uri="{BB962C8B-B14F-4D97-AF65-F5344CB8AC3E}">
@@ -6254,7 +7041,7 @@
 </p:sld>
 </file>
 
-<file path=ppt/slides/slide5.xml><?xml version="1.0" encoding="utf-8"?>
+<file path=ppt/slides/slide6.xml><?xml version="1.0" encoding="utf-8"?>
 <p:sld xmlns:a="http://schemas.openxmlformats.org/drawingml/2006/main" xmlns:r="http://schemas.openxmlformats.org/officeDocument/2006/relationships" xmlns:p="http://schemas.openxmlformats.org/presentationml/2006/main">
   <p:cSld>
     <p:bg>
@@ -6351,7 +7138,7 @@
           <a:p>
             <a:fld id="{0DD1D0E6-76F4-4C79-BDAB-E751C35221FD}" type="slidenum">
               <a:rPr lang="en-US" smtClean="0"/>
-              <a:t>5</a:t>
+              <a:t>6</a:t>
             </a:fld>
             <a:endParaRPr lang="en-US"/>
           </a:p>
@@ -7354,7 +8141,7 @@
 </p:sld>
 </file>
 
-<file path=ppt/slides/slide6.xml><?xml version="1.0" encoding="utf-8"?>
+<file path=ppt/slides/slide7.xml><?xml version="1.0" encoding="utf-8"?>
 <p:sld xmlns:a="http://schemas.openxmlformats.org/drawingml/2006/main" xmlns:r="http://schemas.openxmlformats.org/officeDocument/2006/relationships" xmlns:p="http://schemas.openxmlformats.org/presentationml/2006/main">
   <p:cSld>
     <p:bg>
@@ -7451,7 +8238,7 @@
           <a:p>
             <a:fld id="{0DD1D0E6-76F4-4C79-BDAB-E751C35221FD}" type="slidenum">
               <a:rPr lang="en-US" smtClean="0"/>
-              <a:t>6</a:t>
+              <a:t>7</a:t>
             </a:fld>
             <a:endParaRPr lang="en-US"/>
           </a:p>

</xml_diff>